<commit_message>
style: update world model panel and memory bar styling with custom border-based decorations and updated typography
</commit_message>
<xml_diff>
--- a/docs/presentation/file-3/slide-13-architecture.pptx
+++ b/docs/presentation/file-3/slide-13-architecture.pptx
@@ -942,16 +942,20 @@
         </p:nvSpPr>
         <p:spPr>
           <a:xfrm>
-            <a:off x="1828800" y="3186684"/>
-            <a:ext cx="8534095" cy="27432"/>
-          </a:xfrm>
-          <a:prstGeom prst="rect">
-            <a:avLst/>
-          </a:prstGeom>
-          <a:solidFill>
-            <a:srgbClr val="D4CFC8"/>
-          </a:solidFill>
-          <a:ln/>
+            <a:off x="3524098" y="3200400"/>
+            <a:ext cx="1381658" cy="0"/>
+          </a:xfrm>
+          <a:prstGeom prst="line">
+            <a:avLst/>
+          </a:prstGeom>
+          <a:noFill/>
+          <a:ln w="25400">
+            <a:solidFill>
+              <a:srgbClr val="A8A196"/>
+            </a:solidFill>
+            <a:prstDash val="solid"/>
+            <a:tailEnd type="triangle"/>
+          </a:ln>
         </p:spPr>
       </p:sp>
       <p:sp>
@@ -962,8 +966,32 @@
         </p:nvSpPr>
         <p:spPr>
           <a:xfrm>
-            <a:off x="3528670" y="3054096"/>
-            <a:ext cx="1371600" cy="292608"/>
+            <a:off x="7286854" y="3200400"/>
+            <a:ext cx="1380744" cy="0"/>
+          </a:xfrm>
+          <a:prstGeom prst="line">
+            <a:avLst/>
+          </a:prstGeom>
+          <a:noFill/>
+          <a:ln w="25400">
+            <a:solidFill>
+              <a:srgbClr val="A8A196"/>
+            </a:solidFill>
+            <a:prstDash val="solid"/>
+            <a:tailEnd type="triangle"/>
+          </a:ln>
+        </p:spPr>
+      </p:sp>
+      <p:sp>
+        <p:nvSpPr>
+          <p:cNvPr id="6" name="Shape 4"/>
+          <p:cNvSpPr/>
+          <p:nvPr/>
+        </p:nvSpPr>
+        <p:spPr>
+          <a:xfrm>
+            <a:off x="3734410" y="3054096"/>
+            <a:ext cx="960120" cy="292608"/>
           </a:xfrm>
           <a:prstGeom prst="roundRect">
             <a:avLst>
@@ -992,14 +1020,14 @@
       </p:sp>
       <p:sp>
         <p:nvSpPr>
-          <p:cNvPr id="6" name="Text 4"/>
+          <p:cNvPr id="7" name="Text 5"/>
           <p:cNvSpPr txBox="1"/>
           <p:nvPr/>
         </p:nvSpPr>
         <p:spPr>
           <a:xfrm>
-            <a:off x="3528670" y="3054096"/>
-            <a:ext cx="1371600" cy="292608"/>
+            <a:off x="3734410" y="3054096"/>
+            <a:ext cx="960120" cy="292608"/>
           </a:xfrm>
           <a:prstGeom prst="rect">
             <a:avLst/>
@@ -1031,14 +1059,14 @@
       </p:sp>
       <p:sp>
         <p:nvSpPr>
-          <p:cNvPr id="7" name="Shape 5"/>
+          <p:cNvPr id="8" name="Shape 6"/>
           <p:cNvSpPr/>
           <p:nvPr/>
         </p:nvSpPr>
         <p:spPr>
           <a:xfrm>
-            <a:off x="7291426" y="3054096"/>
-            <a:ext cx="1371600" cy="292608"/>
+            <a:off x="7497166" y="3054096"/>
+            <a:ext cx="960120" cy="292608"/>
           </a:xfrm>
           <a:prstGeom prst="roundRect">
             <a:avLst>
@@ -1067,14 +1095,14 @@
       </p:sp>
       <p:sp>
         <p:nvSpPr>
-          <p:cNvPr id="8" name="Text 6"/>
+          <p:cNvPr id="9" name="Text 7"/>
           <p:cNvSpPr txBox="1"/>
           <p:nvPr/>
         </p:nvSpPr>
         <p:spPr>
           <a:xfrm>
-            <a:off x="7291426" y="3054096"/>
-            <a:ext cx="1371600" cy="292608"/>
+            <a:off x="7497166" y="3054096"/>
+            <a:ext cx="960120" cy="292608"/>
           </a:xfrm>
           <a:prstGeom prst="rect">
             <a:avLst/>
@@ -1106,7 +1134,7 @@
       </p:sp>
       <p:sp>
         <p:nvSpPr>
-          <p:cNvPr id="9" name="Shape 7"/>
+          <p:cNvPr id="10" name="Shape 8"/>
           <p:cNvSpPr/>
           <p:nvPr/>
         </p:nvSpPr>
@@ -1138,7 +1166,7 @@
       </p:sp>
       <p:sp>
         <p:nvSpPr>
-          <p:cNvPr id="10" name="Text 8"/>
+          <p:cNvPr id="11" name="Text 9"/>
           <p:cNvSpPr txBox="1"/>
           <p:nvPr/>
         </p:nvSpPr>
@@ -1177,7 +1205,7 @@
       </p:sp>
       <p:sp>
         <p:nvSpPr>
-          <p:cNvPr id="11" name="Text 9"/>
+          <p:cNvPr id="12" name="Text 10"/>
           <p:cNvSpPr txBox="1"/>
           <p:nvPr/>
         </p:nvSpPr>
@@ -1216,7 +1244,7 @@
       </p:sp>
       <p:sp>
         <p:nvSpPr>
-          <p:cNvPr id="12" name="Text 10"/>
+          <p:cNvPr id="13" name="Text 11"/>
           <p:cNvSpPr txBox="1"/>
           <p:nvPr/>
         </p:nvSpPr>
@@ -1255,7 +1283,7 @@
       </p:sp>
       <p:sp>
         <p:nvSpPr>
-          <p:cNvPr id="13" name="Shape 11"/>
+          <p:cNvPr id="14" name="Shape 12"/>
           <p:cNvSpPr/>
           <p:nvPr/>
         </p:nvSpPr>
@@ -1287,7 +1315,7 @@
       </p:sp>
       <p:sp>
         <p:nvSpPr>
-          <p:cNvPr id="14" name="Text 12"/>
+          <p:cNvPr id="15" name="Text 13"/>
           <p:cNvSpPr txBox="1"/>
           <p:nvPr/>
         </p:nvSpPr>
@@ -1326,7 +1354,7 @@
       </p:sp>
       <p:sp>
         <p:nvSpPr>
-          <p:cNvPr id="15" name="Text 13"/>
+          <p:cNvPr id="16" name="Text 14"/>
           <p:cNvSpPr txBox="1"/>
           <p:nvPr/>
         </p:nvSpPr>
@@ -1365,7 +1393,7 @@
       </p:sp>
       <p:sp>
         <p:nvSpPr>
-          <p:cNvPr id="16" name="Text 14"/>
+          <p:cNvPr id="17" name="Text 15"/>
           <p:cNvSpPr txBox="1"/>
           <p:nvPr/>
         </p:nvSpPr>
@@ -1404,7 +1432,7 @@
       </p:sp>
       <p:sp>
         <p:nvSpPr>
-          <p:cNvPr id="17" name="Shape 15"/>
+          <p:cNvPr id="18" name="Shape 16"/>
           <p:cNvSpPr/>
           <p:nvPr/>
         </p:nvSpPr>
@@ -1436,7 +1464,7 @@
       </p:sp>
       <p:sp>
         <p:nvSpPr>
-          <p:cNvPr id="18" name="Text 16"/>
+          <p:cNvPr id="19" name="Text 17"/>
           <p:cNvSpPr txBox="1"/>
           <p:nvPr/>
         </p:nvSpPr>
@@ -1475,7 +1503,7 @@
       </p:sp>
       <p:sp>
         <p:nvSpPr>
-          <p:cNvPr id="19" name="Text 17"/>
+          <p:cNvPr id="20" name="Text 18"/>
           <p:cNvSpPr txBox="1"/>
           <p:nvPr/>
         </p:nvSpPr>
@@ -1514,7 +1542,7 @@
       </p:sp>
       <p:sp>
         <p:nvSpPr>
-          <p:cNvPr id="20" name="Text 18"/>
+          <p:cNvPr id="21" name="Text 19"/>
           <p:cNvSpPr txBox="1"/>
           <p:nvPr/>
         </p:nvSpPr>
@@ -1553,7 +1581,7 @@
       </p:sp>
       <p:sp>
         <p:nvSpPr>
-          <p:cNvPr id="21" name="Text 19"/>
+          <p:cNvPr id="22" name="Text 20"/>
           <p:cNvSpPr txBox="1"/>
           <p:nvPr/>
         </p:nvSpPr>
@@ -1584,7 +1612,7 @@
                 <a:ea typeface="Playfair Display" pitchFamily="34" charset="-122"/>
                 <a:cs typeface="Playfair Display" pitchFamily="34" charset="-120"/>
               </a:rPr>
-              <a:t>RedGrid asks: does connecting</a:t>
+              <a:t>RedGrid asks whether connecting</a:t>
             </a:r>
             <a:endParaRPr lang="en-US" sz="1950" dirty="0"/>
           </a:p>
@@ -1592,7 +1620,7 @@
       </p:sp>
       <p:sp>
         <p:nvSpPr>
-          <p:cNvPr id="22" name="Text 20"/>
+          <p:cNvPr id="23" name="Text 21"/>
           <p:cNvSpPr txBox="1"/>
           <p:nvPr/>
         </p:nvSpPr>
@@ -1631,7 +1659,7 @@
       </p:sp>
       <p:sp>
         <p:nvSpPr>
-          <p:cNvPr id="23" name="Shape 21"/>
+          <p:cNvPr id="24" name="Shape 22"/>
           <p:cNvSpPr/>
           <p:nvPr/>
         </p:nvSpPr>
@@ -1665,7 +1693,7 @@
       </p:sp>
       <p:sp>
         <p:nvSpPr>
-          <p:cNvPr id="24" name="Text 22"/>
+          <p:cNvPr id="25" name="Text 23"/>
           <p:cNvSpPr txBox="1"/>
           <p:nvPr/>
         </p:nvSpPr>
@@ -1704,7 +1732,7 @@
       </p:sp>
       <p:sp>
         <p:nvSpPr>
-          <p:cNvPr id="25" name="Text 23"/>
+          <p:cNvPr id="26" name="Text 24"/>
           <p:cNvSpPr txBox="1"/>
           <p:nvPr/>
         </p:nvSpPr>
@@ -1743,7 +1771,7 @@
       </p:sp>
       <p:sp>
         <p:nvSpPr>
-          <p:cNvPr id="26" name="Shape 24"/>
+          <p:cNvPr id="27" name="Shape 25"/>
           <p:cNvSpPr/>
           <p:nvPr/>
         </p:nvSpPr>
@@ -1777,7 +1805,7 @@
       </p:sp>
       <p:sp>
         <p:nvSpPr>
-          <p:cNvPr id="27" name="Text 25"/>
+          <p:cNvPr id="28" name="Text 26"/>
           <p:cNvSpPr txBox="1"/>
           <p:nvPr/>
         </p:nvSpPr>
@@ -1816,7 +1844,7 @@
       </p:sp>
       <p:sp>
         <p:nvSpPr>
-          <p:cNvPr id="28" name="Text 26"/>
+          <p:cNvPr id="29" name="Text 27"/>
           <p:cNvSpPr txBox="1"/>
           <p:nvPr/>
         </p:nvSpPr>
@@ -1855,7 +1883,7 @@
       </p:sp>
       <p:sp>
         <p:nvSpPr>
-          <p:cNvPr id="29" name="Shape 27"/>
+          <p:cNvPr id="30" name="Shape 28"/>
           <p:cNvSpPr/>
           <p:nvPr/>
         </p:nvSpPr>
@@ -1889,7 +1917,7 @@
       </p:sp>
       <p:sp>
         <p:nvSpPr>
-          <p:cNvPr id="30" name="Text 28"/>
+          <p:cNvPr id="31" name="Text 29"/>
           <p:cNvSpPr txBox="1"/>
           <p:nvPr/>
         </p:nvSpPr>
@@ -1928,7 +1956,7 @@
       </p:sp>
       <p:sp>
         <p:nvSpPr>
-          <p:cNvPr id="31" name="Shape 29"/>
+          <p:cNvPr id="32" name="Shape 30"/>
           <p:cNvSpPr/>
           <p:nvPr/>
         </p:nvSpPr>
@@ -1948,7 +1976,7 @@
       </p:sp>
       <p:sp>
         <p:nvSpPr>
-          <p:cNvPr id="32" name="Text 30"/>
+          <p:cNvPr id="33" name="Text 31"/>
           <p:cNvSpPr txBox="1"/>
           <p:nvPr/>
         </p:nvSpPr>
@@ -1987,7 +2015,7 @@
       </p:sp>
       <p:sp>
         <p:nvSpPr>
-          <p:cNvPr id="33" name="Shape 31"/>
+          <p:cNvPr id="34" name="Shape 32"/>
           <p:cNvSpPr/>
           <p:nvPr/>
         </p:nvSpPr>

</xml_diff>